<commit_message>
Update critique C and D slides with checklist coverage
</commit_message>
<xml_diff>
--- a/critique_C/DSA5206_Critique_C.pptx
+++ b/critique_C/DSA5206_Critique_C.pptx
@@ -504,7 +504,7 @@
           <a:p>
             <a:r>
               <a:rPr lang="en-US" dirty="0"/>
-              <a:t>Where does the data come from? All 94 images were scraped from public sources. 39 are figures cut out of journal articles, 26 come from case reports of the Italian radiology society SIRM, 18 from Radiopaedia, 8 from a PDF published by the Academy of Medicine Singapore, and 3 from other case-sharing sites. They belong to 65 patients, so many patients contribute several time points. Geographically, Italy dominates with 29 images, and 19 images have no location at all. There is nothing from Africa, South America or South Asia, and every image is from the first three months of the pandemic. These are cases someone chose to publish, typically interesting or severe ones, so this is a convenience sample with publication bias, not a clinical cohort. On ethics: the paper reports approval from the CERSES ethics committee and says consent was obtained or waived; since the images were taken from publications, it can only have been waived. Licensing is also unclear: 66 of the 94 images have no licence recorded in the dataset metadata.</a:t>
+              <a:t>Where does the data come from? All 94 images were scraped from public sources. 39 are figures cut out of journal articles, 26 come from case reports of the Italian radiology society SIRM, 18 from Radiopaedia, 8 from a PDF published by the Academy of Medicine Singapore, and 3 from other case-sharing sites. They belong to 65 patients, so many patients contribute several time points. Geographically, Italy dominates with 29 images, and 19 images have no location at all. There is nothing from Africa, South America or South Asia, and every image is from the first three months of the pandemic. These are cases someone chose to publish, typically interesting or severe ones, so this is a convenience sample, not a clinical cohort. In the lecture’s terms that is sampling bias, institutional bias from a handful of hospitals and websites, and demographic bias, since no population is described beyond age and sex. On ethics: the paper reports approval from the CERSES ethics committee and says consent was obtained or waived; since the images were taken from publications, it can only have been waived. The study was not registered, which is common for a retrospective study on public data, but the lecture checklist asks for it. Licensing is also unclear: 66 of the 94 images have no licence recorded in the dataset metadata.</a:t>
             </a:r>
             <a:endParaRPr lang="en-US" dirty="0"/>
           </a:p>
@@ -2066,7 +2066,7 @@
                 <a:ea typeface="Arial" pitchFamily="34" charset="-122"/>
                 <a:cs typeface="Arial" pitchFamily="34" charset="-120"/>
               </a:rPr>
-              <a:t>Ethics and licensing</a:t>
+              <a:t>Ethics, registration and licensing</a:t>
             </a:r>
             <a:endParaRPr lang="en-US" sz="1300" dirty="0"/>
           </a:p>
@@ -2110,7 +2110,7 @@
                 <a:ea typeface="Arial" pitchFamily="34" charset="-122"/>
                 <a:cs typeface="Arial" pitchFamily="34" charset="-120"/>
               </a:rPr>
-              <a:t>Approved by CERSES (#CERSES-20-058-D); consent “obtained or waived”, in practice waived for published images. License not recorded for 66 of 94.</a:t>
+              <a:t>Approved by CERSES (#CERSES-20-058-D); consent “obtained or waived”, in practice waived. Not registered. License not recorded for 66 of 94.</a:t>
             </a:r>
             <a:endParaRPr lang="en-US" sz="1200" dirty="0"/>
           </a:p>
@@ -2154,7 +2154,7 @@
                 <a:ea typeface="Arial" pitchFamily="34" charset="-122"/>
                 <a:cs typeface="Arial" pitchFamily="34" charset="-120"/>
               </a:rPr>
-              <a:t>Bias: publication, sampling and institutional</a:t>
+              <a:t>Bias: sampling, institutional and demographic</a:t>
             </a:r>
             <a:endParaRPr lang="en-US" sz="1200" dirty="0"/>
           </a:p>
@@ -4003,7 +4003,7 @@
         <p:spPr>
           <a:xfrm>
             <a:off x="6518656" y="3052961"/>
-            <a:ext cx="4779709" cy="878681"/>
+            <a:ext cx="4779709" cy="1092002"/>
           </a:xfrm>
           <a:prstGeom prst="rect">
             <a:avLst/>
@@ -4076,6 +4076,27 @@
                 <a:cs typeface="Arial" pitchFamily="34" charset="-120"/>
               </a:rPr>
               <a:t>5 more show burned-in “AP Sitting”, “MOBILE ERECT AP” or “CLINO” (lying) but are still labelled PA</a:t>
+            </a:r>
+            <a:endParaRPr lang="en-US" sz="1200" dirty="0"/>
+          </a:p>
+          <a:p>
+            <a:pPr algn="l" marL="142494" indent="-142494">
+              <a:lnSpc>
+                <a:spcPts val="1680"/>
+              </a:lnSpc>
+              <a:buSzPct val="100000"/>
+              <a:buChar char="•"/>
+            </a:pPr>
+            <a:r>
+              <a:rPr lang="en-US" sz="1200" dirty="0">
+                <a:solidFill>
+                  <a:srgbClr val="3E4A5C"/>
+                </a:solidFill>
+                <a:latin typeface="Arial" pitchFamily="34" charset="0"/>
+                <a:ea typeface="Arial" pitchFamily="34" charset="-122"/>
+                <a:cs typeface="Arial" pitchFamily="34" charset="-120"/>
+              </a:rPr>
+              <a:t>No exclusion criteria stated</a:t>
             </a:r>
             <a:endParaRPr lang="en-US" sz="1200" dirty="0"/>
           </a:p>
@@ -4151,7 +4172,7 @@
                 <a:ea typeface="Arial" pitchFamily="34" charset="-122"/>
                 <a:cs typeface="Arial" pitchFamily="34" charset="-120"/>
               </a:rPr>
-              <a:t>PART II · CRITIQUE ② DATA PREPARATION</a:t>
+              <a:t>PART II · CRITIQUE ② DATA PREPARATION · ANNOTATION AND MEASUREMENT BIAS</a:t>
             </a:r>
             <a:endParaRPr lang="en-US" sz="1200" dirty="0"/>
           </a:p>

</xml_diff>